<commit_message>
Align DICE deck to finalist slide count
</commit_message>
<xml_diff>
--- a/DICE Challenge S3 - Slayed it Winning Submission.pptx
+++ b/DICE Challenge S3 - Slayed it Winning Submission.pptx
@@ -19,6 +19,7 @@
     <p:sldId id="264" r:id="rId15"/>
     <p:sldId id="265" r:id="rId16"/>
     <p:sldId id="266" r:id="rId17"/>
+    <p:sldId id="267" r:id="rId18"/>
   </p:sldIdLst>
   <p:sldSz cy="10287000" cx="18288000"/>
   <p:notesSz cx="6858000" cy="9144000"/>
@@ -10894,6 +10895,48 @@
       <p:pic>
         <p:nvPicPr>
           <p:cNvPr id="2" name="Picture 1" descr="slide_11.png"/>
+          <p:cNvPicPr>
+            <a:picLocks noChangeAspect="1"/>
+          </p:cNvPicPr>
+          <p:nvPr/>
+        </p:nvPicPr>
+        <p:blipFill>
+          <a:blip r:embed="rId2"/>
+          <a:stretch>
+            <a:fillRect/>
+          </a:stretch>
+        </p:blipFill>
+        <p:spPr>
+          <a:xfrm>
+            <a:off x="0" y="0"/>
+            <a:ext cx="18288000" cy="10287000"/>
+          </a:xfrm>
+          <a:prstGeom prst="rect">
+            <a:avLst/>
+          </a:prstGeom>
+        </p:spPr>
+      </p:pic>
+    </p:spTree>
+  </p:cSld>
+  <p:clrMapOvr>
+    <a:masterClrMapping/>
+  </p:clrMapOvr>
+</p:sld>
+</file>
+
+<file path=ppt/slides/slide12.xml><?xml version="1.0" encoding="utf-8"?>
+<p:sld xmlns:a="http://schemas.openxmlformats.org/drawingml/2006/main" xmlns:p="http://schemas.openxmlformats.org/presentationml/2006/main" xmlns:r="http://schemas.openxmlformats.org/officeDocument/2006/relationships">
+  <p:cSld>
+    <p:spTree>
+      <p:nvGrpSpPr>
+        <p:cNvPr id="1" name=""/>
+        <p:cNvGrpSpPr/>
+        <p:nvPr/>
+      </p:nvGrpSpPr>
+      <p:grpSpPr/>
+      <p:pic>
+        <p:nvPicPr>
+          <p:cNvPr id="2" name="Picture 1" descr="slide_12.png"/>
           <p:cNvPicPr>
             <a:picLocks noChangeAspect="1"/>
           </p:cNvPicPr>

</xml_diff>

<commit_message>
Refine DICE deck visual boards
</commit_message>
<xml_diff>
--- a/DICE Challenge S3 - Slayed it Winning Submission.pptx
+++ b/DICE Challenge S3 - Slayed it Winning Submission.pptx
@@ -10958,6 +10958,51 @@
           </a:prstGeom>
         </p:spPr>
       </p:pic>
+      <p:sp>
+        <p:nvSpPr>
+          <p:cNvPr id="3" name="Rectangle 2">
+            <a:hlinkClick r:id="rId3"/>
+          </p:cNvPr>
+          <p:cNvSpPr/>
+          <p:nvPr/>
+        </p:nvSpPr>
+        <p:spPr>
+          <a:xfrm>
+            <a:off x="411480" y="9601200"/>
+            <a:ext cx="17373600" cy="411480"/>
+          </a:xfrm>
+          <a:prstGeom prst="rect">
+            <a:avLst/>
+          </a:prstGeom>
+          <a:solidFill>
+            <a:srgbClr val="FFFFFF"/>
+          </a:solidFill>
+          <a:ln>
+            <a:noFill/>
+          </a:ln>
+        </p:spPr>
+        <p:style>
+          <a:lnRef idx="1">
+            <a:schemeClr val="accent1"/>
+          </a:lnRef>
+          <a:fillRef idx="3">
+            <a:schemeClr val="accent1"/>
+          </a:fillRef>
+          <a:effectRef idx="2">
+            <a:schemeClr val="accent1"/>
+          </a:effectRef>
+          <a:fontRef idx="minor">
+            <a:schemeClr val="lt1"/>
+          </a:fontRef>
+        </p:style>
+        <p:txBody>
+          <a:bodyPr rtlCol="0" anchor="ctr"/>
+          <a:lstStyle/>
+          <a:p>
+            <a:pPr algn="ctr"/>
+          </a:p>
+        </p:txBody>
+      </p:sp>
     </p:spTree>
   </p:cSld>
   <p:clrMapOvr>
@@ -11007,6 +11052,51 @@
           </a:prstGeom>
         </p:spPr>
       </p:pic>
+      <p:sp>
+        <p:nvSpPr>
+          <p:cNvPr id="91" name="Rectangle 90">
+            <a:hlinkClick r:id="rId7"/>
+          </p:cNvPr>
+          <p:cNvSpPr/>
+          <p:nvPr/>
+        </p:nvSpPr>
+        <p:spPr>
+          <a:xfrm>
+            <a:off x="411480" y="9601200"/>
+            <a:ext cx="6400800" cy="411480"/>
+          </a:xfrm>
+          <a:prstGeom prst="rect">
+            <a:avLst/>
+          </a:prstGeom>
+          <a:solidFill>
+            <a:srgbClr val="FFFFFF"/>
+          </a:solidFill>
+          <a:ln>
+            <a:noFill/>
+          </a:ln>
+        </p:spPr>
+        <p:style>
+          <a:lnRef idx="1">
+            <a:schemeClr val="accent1"/>
+          </a:lnRef>
+          <a:fillRef idx="3">
+            <a:schemeClr val="accent1"/>
+          </a:fillRef>
+          <a:effectRef idx="2">
+            <a:schemeClr val="accent1"/>
+          </a:effectRef>
+          <a:fontRef idx="minor">
+            <a:schemeClr val="lt1"/>
+          </a:fontRef>
+        </p:style>
+        <p:txBody>
+          <a:bodyPr rtlCol="0" anchor="ctr"/>
+          <a:lstStyle/>
+          <a:p>
+            <a:pPr algn="ctr"/>
+          </a:p>
+        </p:txBody>
+      </p:sp>
     </p:spTree>
   </p:cSld>
   <p:clrMapOvr>
@@ -11056,6 +11146,96 @@
           </a:prstGeom>
         </p:spPr>
       </p:pic>
+      <p:sp>
+        <p:nvSpPr>
+          <p:cNvPr id="103" name="Rectangle 102">
+            <a:hlinkClick r:id="rId7"/>
+          </p:cNvPr>
+          <p:cNvSpPr/>
+          <p:nvPr/>
+        </p:nvSpPr>
+        <p:spPr>
+          <a:xfrm>
+            <a:off x="12893040" y="2423160"/>
+            <a:ext cx="4297680" cy="502920"/>
+          </a:xfrm>
+          <a:prstGeom prst="rect">
+            <a:avLst/>
+          </a:prstGeom>
+          <a:solidFill>
+            <a:srgbClr val="FFFFFF"/>
+          </a:solidFill>
+          <a:ln>
+            <a:noFill/>
+          </a:ln>
+        </p:spPr>
+        <p:style>
+          <a:lnRef idx="1">
+            <a:schemeClr val="accent1"/>
+          </a:lnRef>
+          <a:fillRef idx="3">
+            <a:schemeClr val="accent1"/>
+          </a:fillRef>
+          <a:effectRef idx="2">
+            <a:schemeClr val="accent1"/>
+          </a:effectRef>
+          <a:fontRef idx="minor">
+            <a:schemeClr val="lt1"/>
+          </a:fontRef>
+        </p:style>
+        <p:txBody>
+          <a:bodyPr rtlCol="0" anchor="ctr"/>
+          <a:lstStyle/>
+          <a:p>
+            <a:pPr algn="ctr"/>
+          </a:p>
+        </p:txBody>
+      </p:sp>
+      <p:sp>
+        <p:nvSpPr>
+          <p:cNvPr id="104" name="Rectangle 103">
+            <a:hlinkClick r:id="rId8"/>
+          </p:cNvPr>
+          <p:cNvSpPr/>
+          <p:nvPr/>
+        </p:nvSpPr>
+        <p:spPr>
+          <a:xfrm>
+            <a:off x="12893040" y="7543800"/>
+            <a:ext cx="4297680" cy="640080"/>
+          </a:xfrm>
+          <a:prstGeom prst="rect">
+            <a:avLst/>
+          </a:prstGeom>
+          <a:solidFill>
+            <a:srgbClr val="FFFFFF"/>
+          </a:solidFill>
+          <a:ln>
+            <a:noFill/>
+          </a:ln>
+        </p:spPr>
+        <p:style>
+          <a:lnRef idx="1">
+            <a:schemeClr val="accent1"/>
+          </a:lnRef>
+          <a:fillRef idx="3">
+            <a:schemeClr val="accent1"/>
+          </a:fillRef>
+          <a:effectRef idx="2">
+            <a:schemeClr val="accent1"/>
+          </a:effectRef>
+          <a:fontRef idx="minor">
+            <a:schemeClr val="lt1"/>
+          </a:fontRef>
+        </p:style>
+        <p:txBody>
+          <a:bodyPr rtlCol="0" anchor="ctr"/>
+          <a:lstStyle/>
+          <a:p>
+            <a:pPr algn="ctr"/>
+          </a:p>
+        </p:txBody>
+      </p:sp>
     </p:spTree>
   </p:cSld>
   <p:clrMapOvr>
@@ -11105,6 +11285,51 @@
           </a:prstGeom>
         </p:spPr>
       </p:pic>
+      <p:sp>
+        <p:nvSpPr>
+          <p:cNvPr id="115" name="Rectangle 114">
+            <a:hlinkClick r:id="rId7"/>
+          </p:cNvPr>
+          <p:cNvSpPr/>
+          <p:nvPr/>
+        </p:nvSpPr>
+        <p:spPr>
+          <a:xfrm>
+            <a:off x="411480" y="9601200"/>
+            <a:ext cx="7315200" cy="411480"/>
+          </a:xfrm>
+          <a:prstGeom prst="rect">
+            <a:avLst/>
+          </a:prstGeom>
+          <a:solidFill>
+            <a:srgbClr val="FFFFFF"/>
+          </a:solidFill>
+          <a:ln>
+            <a:noFill/>
+          </a:ln>
+        </p:spPr>
+        <p:style>
+          <a:lnRef idx="1">
+            <a:schemeClr val="accent1"/>
+          </a:lnRef>
+          <a:fillRef idx="3">
+            <a:schemeClr val="accent1"/>
+          </a:fillRef>
+          <a:effectRef idx="2">
+            <a:schemeClr val="accent1"/>
+          </a:effectRef>
+          <a:fontRef idx="minor">
+            <a:schemeClr val="lt1"/>
+          </a:fontRef>
+        </p:style>
+        <p:txBody>
+          <a:bodyPr rtlCol="0" anchor="ctr"/>
+          <a:lstStyle/>
+          <a:p>
+            <a:pPr algn="ctr"/>
+          </a:p>
+        </p:txBody>
+      </p:sp>
     </p:spTree>
   </p:cSld>
   <p:clrMapOvr>
@@ -11238,6 +11463,186 @@
           </a:prstGeom>
         </p:spPr>
       </p:pic>
+      <p:sp>
+        <p:nvSpPr>
+          <p:cNvPr id="3" name="Rectangle 2">
+            <a:hlinkClick r:id="rId3"/>
+          </p:cNvPr>
+          <p:cNvSpPr/>
+          <p:nvPr/>
+        </p:nvSpPr>
+        <p:spPr>
+          <a:xfrm>
+            <a:off x="411480" y="2468880"/>
+            <a:ext cx="17373600" cy="713232"/>
+          </a:xfrm>
+          <a:prstGeom prst="rect">
+            <a:avLst/>
+          </a:prstGeom>
+          <a:solidFill>
+            <a:srgbClr val="FFFFFF"/>
+          </a:solidFill>
+          <a:ln>
+            <a:noFill/>
+          </a:ln>
+        </p:spPr>
+        <p:style>
+          <a:lnRef idx="1">
+            <a:schemeClr val="accent1"/>
+          </a:lnRef>
+          <a:fillRef idx="3">
+            <a:schemeClr val="accent1"/>
+          </a:fillRef>
+          <a:effectRef idx="2">
+            <a:schemeClr val="accent1"/>
+          </a:effectRef>
+          <a:fontRef idx="minor">
+            <a:schemeClr val="lt1"/>
+          </a:fontRef>
+        </p:style>
+        <p:txBody>
+          <a:bodyPr rtlCol="0" anchor="ctr"/>
+          <a:lstStyle/>
+          <a:p>
+            <a:pPr algn="ctr"/>
+          </a:p>
+        </p:txBody>
+      </p:sp>
+      <p:sp>
+        <p:nvSpPr>
+          <p:cNvPr id="4" name="Rectangle 3">
+            <a:hlinkClick r:id="rId4"/>
+          </p:cNvPr>
+          <p:cNvSpPr/>
+          <p:nvPr/>
+        </p:nvSpPr>
+        <p:spPr>
+          <a:xfrm>
+            <a:off x="411480" y="3246120"/>
+            <a:ext cx="17373600" cy="713232"/>
+          </a:xfrm>
+          <a:prstGeom prst="rect">
+            <a:avLst/>
+          </a:prstGeom>
+          <a:solidFill>
+            <a:srgbClr val="FFFFFF"/>
+          </a:solidFill>
+          <a:ln>
+            <a:noFill/>
+          </a:ln>
+        </p:spPr>
+        <p:style>
+          <a:lnRef idx="1">
+            <a:schemeClr val="accent1"/>
+          </a:lnRef>
+          <a:fillRef idx="3">
+            <a:schemeClr val="accent1"/>
+          </a:fillRef>
+          <a:effectRef idx="2">
+            <a:schemeClr val="accent1"/>
+          </a:effectRef>
+          <a:fontRef idx="minor">
+            <a:schemeClr val="lt1"/>
+          </a:fontRef>
+        </p:style>
+        <p:txBody>
+          <a:bodyPr rtlCol="0" anchor="ctr"/>
+          <a:lstStyle/>
+          <a:p>
+            <a:pPr algn="ctr"/>
+          </a:p>
+        </p:txBody>
+      </p:sp>
+      <p:sp>
+        <p:nvSpPr>
+          <p:cNvPr id="5" name="Rectangle 4">
+            <a:hlinkClick r:id="rId5"/>
+          </p:cNvPr>
+          <p:cNvSpPr/>
+          <p:nvPr/>
+        </p:nvSpPr>
+        <p:spPr>
+          <a:xfrm>
+            <a:off x="411480" y="4023360"/>
+            <a:ext cx="17373600" cy="713232"/>
+          </a:xfrm>
+          <a:prstGeom prst="rect">
+            <a:avLst/>
+          </a:prstGeom>
+          <a:solidFill>
+            <a:srgbClr val="FFFFFF"/>
+          </a:solidFill>
+          <a:ln>
+            <a:noFill/>
+          </a:ln>
+        </p:spPr>
+        <p:style>
+          <a:lnRef idx="1">
+            <a:schemeClr val="accent1"/>
+          </a:lnRef>
+          <a:fillRef idx="3">
+            <a:schemeClr val="accent1"/>
+          </a:fillRef>
+          <a:effectRef idx="2">
+            <a:schemeClr val="accent1"/>
+          </a:effectRef>
+          <a:fontRef idx="minor">
+            <a:schemeClr val="lt1"/>
+          </a:fontRef>
+        </p:style>
+        <p:txBody>
+          <a:bodyPr rtlCol="0" anchor="ctr"/>
+          <a:lstStyle/>
+          <a:p>
+            <a:pPr algn="ctr"/>
+          </a:p>
+        </p:txBody>
+      </p:sp>
+      <p:sp>
+        <p:nvSpPr>
+          <p:cNvPr id="6" name="Rectangle 5">
+            <a:hlinkClick r:id="rId6"/>
+          </p:cNvPr>
+          <p:cNvSpPr/>
+          <p:nvPr/>
+        </p:nvSpPr>
+        <p:spPr>
+          <a:xfrm>
+            <a:off x="411480" y="4800600"/>
+            <a:ext cx="17373600" cy="713232"/>
+          </a:xfrm>
+          <a:prstGeom prst="rect">
+            <a:avLst/>
+          </a:prstGeom>
+          <a:solidFill>
+            <a:srgbClr val="FFFFFF"/>
+          </a:solidFill>
+          <a:ln>
+            <a:noFill/>
+          </a:ln>
+        </p:spPr>
+        <p:style>
+          <a:lnRef idx="1">
+            <a:schemeClr val="accent1"/>
+          </a:lnRef>
+          <a:fillRef idx="3">
+            <a:schemeClr val="accent1"/>
+          </a:fillRef>
+          <a:effectRef idx="2">
+            <a:schemeClr val="accent1"/>
+          </a:effectRef>
+          <a:fontRef idx="minor">
+            <a:schemeClr val="lt1"/>
+          </a:fontRef>
+        </p:style>
+        <p:txBody>
+          <a:bodyPr rtlCol="0" anchor="ctr"/>
+          <a:lstStyle/>
+          <a:p>
+            <a:pPr algn="ctr"/>
+          </a:p>
+        </p:txBody>
+      </p:sp>
     </p:spTree>
   </p:cSld>
   <p:clrMapOvr>

</xml_diff>

<commit_message>
Finalize DICE deck visual QA and source links
</commit_message>
<xml_diff>
--- a/DICE Challenge S3 - Slayed it Winning Submission.pptx
+++ b/DICE Challenge S3 - Slayed it Winning Submission.pptx
@@ -20,6 +20,7 @@
     <p:sldId id="265" r:id="rId16"/>
     <p:sldId id="266" r:id="rId17"/>
     <p:sldId id="267" r:id="rId18"/>
+    <p:sldId id="268" r:id="rId19"/>
   </p:sldIdLst>
   <p:sldSz cy="10287000" cx="18288000"/>
   <p:notesSz cx="6858000" cy="9144000"/>
@@ -10874,6 +10875,51 @@
           </a:prstGeom>
         </p:spPr>
       </p:pic>
+      <p:sp>
+        <p:nvSpPr>
+          <p:cNvPr id="3" name="Rectangle 2">
+            <a:hlinkClick r:id="rId3"/>
+          </p:cNvPr>
+          <p:cNvSpPr/>
+          <p:nvPr/>
+        </p:nvSpPr>
+        <p:spPr>
+          <a:xfrm>
+            <a:off x="411480" y="9601200"/>
+            <a:ext cx="7315200" cy="411480"/>
+          </a:xfrm>
+          <a:prstGeom prst="rect">
+            <a:avLst/>
+          </a:prstGeom>
+          <a:solidFill>
+            <a:srgbClr val="FFFFFF"/>
+          </a:solidFill>
+          <a:ln>
+            <a:noFill/>
+          </a:ln>
+        </p:spPr>
+        <p:style>
+          <a:lnRef idx="1">
+            <a:schemeClr val="accent1"/>
+          </a:lnRef>
+          <a:fillRef idx="3">
+            <a:schemeClr val="accent1"/>
+          </a:fillRef>
+          <a:effectRef idx="2">
+            <a:schemeClr val="accent1"/>
+          </a:effectRef>
+          <a:fontRef idx="minor">
+            <a:schemeClr val="lt1"/>
+          </a:fontRef>
+        </p:style>
+        <p:txBody>
+          <a:bodyPr rtlCol="0" anchor="ctr"/>
+          <a:lstStyle/>
+          <a:p>
+            <a:pPr algn="ctr"/>
+          </a:p>
+        </p:txBody>
+      </p:sp>
     </p:spTree>
   </p:cSld>
   <p:clrMapOvr>
@@ -10916,6 +10962,51 @@
           </a:prstGeom>
         </p:spPr>
       </p:pic>
+      <p:sp>
+        <p:nvSpPr>
+          <p:cNvPr id="3" name="Rectangle 2">
+            <a:hlinkClick r:id="rId3"/>
+          </p:cNvPr>
+          <p:cNvSpPr/>
+          <p:nvPr/>
+        </p:nvSpPr>
+        <p:spPr>
+          <a:xfrm>
+            <a:off x="411480" y="9601200"/>
+            <a:ext cx="7315200" cy="411480"/>
+          </a:xfrm>
+          <a:prstGeom prst="rect">
+            <a:avLst/>
+          </a:prstGeom>
+          <a:solidFill>
+            <a:srgbClr val="FFFFFF"/>
+          </a:solidFill>
+          <a:ln>
+            <a:noFill/>
+          </a:ln>
+        </p:spPr>
+        <p:style>
+          <a:lnRef idx="1">
+            <a:schemeClr val="accent1"/>
+          </a:lnRef>
+          <a:fillRef idx="3">
+            <a:schemeClr val="accent1"/>
+          </a:fillRef>
+          <a:effectRef idx="2">
+            <a:schemeClr val="accent1"/>
+          </a:effectRef>
+          <a:fontRef idx="minor">
+            <a:schemeClr val="lt1"/>
+          </a:fontRef>
+        </p:style>
+        <p:txBody>
+          <a:bodyPr rtlCol="0" anchor="ctr"/>
+          <a:lstStyle/>
+          <a:p>
+            <a:pPr algn="ctr"/>
+          </a:p>
+        </p:txBody>
+      </p:sp>
     </p:spTree>
   </p:cSld>
   <p:clrMapOvr>
@@ -10969,7 +11060,364 @@
         <p:spPr>
           <a:xfrm>
             <a:off x="411480" y="9601200"/>
+            <a:ext cx="7315200" cy="411480"/>
+          </a:xfrm>
+          <a:prstGeom prst="rect">
+            <a:avLst/>
+          </a:prstGeom>
+          <a:solidFill>
+            <a:srgbClr val="FFFFFF"/>
+          </a:solidFill>
+          <a:ln>
+            <a:noFill/>
+          </a:ln>
+        </p:spPr>
+        <p:style>
+          <a:lnRef idx="1">
+            <a:schemeClr val="accent1"/>
+          </a:lnRef>
+          <a:fillRef idx="3">
+            <a:schemeClr val="accent1"/>
+          </a:fillRef>
+          <a:effectRef idx="2">
+            <a:schemeClr val="accent1"/>
+          </a:effectRef>
+          <a:fontRef idx="minor">
+            <a:schemeClr val="lt1"/>
+          </a:fontRef>
+        </p:style>
+        <p:txBody>
+          <a:bodyPr rtlCol="0" anchor="ctr"/>
+          <a:lstStyle/>
+          <a:p>
+            <a:pPr algn="ctr"/>
+          </a:p>
+        </p:txBody>
+      </p:sp>
+    </p:spTree>
+  </p:cSld>
+  <p:clrMapOvr>
+    <a:masterClrMapping/>
+  </p:clrMapOvr>
+</p:sld>
+</file>
+
+<file path=ppt/slides/slide13.xml><?xml version="1.0" encoding="utf-8"?>
+<p:sld xmlns:a="http://schemas.openxmlformats.org/drawingml/2006/main" xmlns:p="http://schemas.openxmlformats.org/presentationml/2006/main" xmlns:r="http://schemas.openxmlformats.org/officeDocument/2006/relationships">
+  <p:cSld>
+    <p:spTree>
+      <p:nvGrpSpPr>
+        <p:cNvPr id="1" name=""/>
+        <p:cNvGrpSpPr/>
+        <p:nvPr/>
+      </p:nvGrpSpPr>
+      <p:grpSpPr/>
+      <p:pic>
+        <p:nvPicPr>
+          <p:cNvPr id="2" name="Picture 1" descr="slide_13.png"/>
+          <p:cNvPicPr>
+            <a:picLocks noChangeAspect="1"/>
+          </p:cNvPicPr>
+          <p:nvPr/>
+        </p:nvPicPr>
+        <p:blipFill>
+          <a:blip r:embed="rId2"/>
+          <a:stretch>
+            <a:fillRect/>
+          </a:stretch>
+        </p:blipFill>
+        <p:spPr>
+          <a:xfrm>
+            <a:off x="0" y="0"/>
+            <a:ext cx="18288000" cy="10287000"/>
+          </a:xfrm>
+          <a:prstGeom prst="rect">
+            <a:avLst/>
+          </a:prstGeom>
+        </p:spPr>
+      </p:pic>
+      <p:sp>
+        <p:nvSpPr>
+          <p:cNvPr id="3" name="Rectangle 2">
+            <a:hlinkClick r:id="rId3"/>
+          </p:cNvPr>
+          <p:cNvSpPr/>
+          <p:nvPr/>
+        </p:nvSpPr>
+        <p:spPr>
+          <a:xfrm>
+            <a:off x="411480" y="9601200"/>
             <a:ext cx="17373600" cy="411480"/>
+          </a:xfrm>
+          <a:prstGeom prst="rect">
+            <a:avLst/>
+          </a:prstGeom>
+          <a:solidFill>
+            <a:srgbClr val="FFFFFF"/>
+          </a:solidFill>
+          <a:ln>
+            <a:noFill/>
+          </a:ln>
+        </p:spPr>
+        <p:style>
+          <a:lnRef idx="1">
+            <a:schemeClr val="accent1"/>
+          </a:lnRef>
+          <a:fillRef idx="3">
+            <a:schemeClr val="accent1"/>
+          </a:fillRef>
+          <a:effectRef idx="2">
+            <a:schemeClr val="accent1"/>
+          </a:effectRef>
+          <a:fontRef idx="minor">
+            <a:schemeClr val="lt1"/>
+          </a:fontRef>
+        </p:style>
+        <p:txBody>
+          <a:bodyPr rtlCol="0" anchor="ctr"/>
+          <a:lstStyle/>
+          <a:p>
+            <a:pPr algn="ctr"/>
+          </a:p>
+        </p:txBody>
+      </p:sp>
+      <p:sp>
+        <p:nvSpPr>
+          <p:cNvPr id="4" name="Rectangle 3">
+            <a:hlinkClick r:id="rId3"/>
+          </p:cNvPr>
+          <p:cNvSpPr/>
+          <p:nvPr/>
+        </p:nvSpPr>
+        <p:spPr>
+          <a:xfrm>
+            <a:off x="11750040" y="6885432"/>
+            <a:ext cx="2560320" cy="502920"/>
+          </a:xfrm>
+          <a:prstGeom prst="rect">
+            <a:avLst/>
+          </a:prstGeom>
+          <a:solidFill>
+            <a:srgbClr val="FFFFFF"/>
+          </a:solidFill>
+          <a:ln>
+            <a:noFill/>
+          </a:ln>
+        </p:spPr>
+        <p:style>
+          <a:lnRef idx="1">
+            <a:schemeClr val="accent1"/>
+          </a:lnRef>
+          <a:fillRef idx="3">
+            <a:schemeClr val="accent1"/>
+          </a:fillRef>
+          <a:effectRef idx="2">
+            <a:schemeClr val="accent1"/>
+          </a:effectRef>
+          <a:fontRef idx="minor">
+            <a:schemeClr val="lt1"/>
+          </a:fontRef>
+        </p:style>
+        <p:txBody>
+          <a:bodyPr rtlCol="0" anchor="ctr"/>
+          <a:lstStyle/>
+          <a:p>
+            <a:pPr algn="ctr"/>
+          </a:p>
+        </p:txBody>
+      </p:sp>
+      <p:sp>
+        <p:nvSpPr>
+          <p:cNvPr id="5" name="Rectangle 4">
+            <a:hlinkClick r:id="rId4"/>
+          </p:cNvPr>
+          <p:cNvSpPr/>
+          <p:nvPr/>
+        </p:nvSpPr>
+        <p:spPr>
+          <a:xfrm>
+            <a:off x="14785848" y="6885432"/>
+            <a:ext cx="2560320" cy="502920"/>
+          </a:xfrm>
+          <a:prstGeom prst="rect">
+            <a:avLst/>
+          </a:prstGeom>
+          <a:solidFill>
+            <a:srgbClr val="FFFFFF"/>
+          </a:solidFill>
+          <a:ln>
+            <a:noFill/>
+          </a:ln>
+        </p:spPr>
+        <p:style>
+          <a:lnRef idx="1">
+            <a:schemeClr val="accent1"/>
+          </a:lnRef>
+          <a:fillRef idx="3">
+            <a:schemeClr val="accent1"/>
+          </a:fillRef>
+          <a:effectRef idx="2">
+            <a:schemeClr val="accent1"/>
+          </a:effectRef>
+          <a:fontRef idx="minor">
+            <a:schemeClr val="lt1"/>
+          </a:fontRef>
+        </p:style>
+        <p:txBody>
+          <a:bodyPr rtlCol="0" anchor="ctr"/>
+          <a:lstStyle/>
+          <a:p>
+            <a:pPr algn="ctr"/>
+          </a:p>
+        </p:txBody>
+      </p:sp>
+      <p:sp>
+        <p:nvSpPr>
+          <p:cNvPr id="6" name="Rectangle 5">
+            <a:hlinkClick r:id="rId5"/>
+          </p:cNvPr>
+          <p:cNvSpPr/>
+          <p:nvPr/>
+        </p:nvSpPr>
+        <p:spPr>
+          <a:xfrm>
+            <a:off x="11750040" y="7534656"/>
+            <a:ext cx="2560320" cy="502920"/>
+          </a:xfrm>
+          <a:prstGeom prst="rect">
+            <a:avLst/>
+          </a:prstGeom>
+          <a:solidFill>
+            <a:srgbClr val="FFFFFF"/>
+          </a:solidFill>
+          <a:ln>
+            <a:noFill/>
+          </a:ln>
+        </p:spPr>
+        <p:style>
+          <a:lnRef idx="1">
+            <a:schemeClr val="accent1"/>
+          </a:lnRef>
+          <a:fillRef idx="3">
+            <a:schemeClr val="accent1"/>
+          </a:fillRef>
+          <a:effectRef idx="2">
+            <a:schemeClr val="accent1"/>
+          </a:effectRef>
+          <a:fontRef idx="minor">
+            <a:schemeClr val="lt1"/>
+          </a:fontRef>
+        </p:style>
+        <p:txBody>
+          <a:bodyPr rtlCol="0" anchor="ctr"/>
+          <a:lstStyle/>
+          <a:p>
+            <a:pPr algn="ctr"/>
+          </a:p>
+        </p:txBody>
+      </p:sp>
+      <p:sp>
+        <p:nvSpPr>
+          <p:cNvPr id="7" name="Rectangle 6">
+            <a:hlinkClick r:id="rId6"/>
+          </p:cNvPr>
+          <p:cNvSpPr/>
+          <p:nvPr/>
+        </p:nvSpPr>
+        <p:spPr>
+          <a:xfrm>
+            <a:off x="14785848" y="7534656"/>
+            <a:ext cx="2560320" cy="502920"/>
+          </a:xfrm>
+          <a:prstGeom prst="rect">
+            <a:avLst/>
+          </a:prstGeom>
+          <a:solidFill>
+            <a:srgbClr val="FFFFFF"/>
+          </a:solidFill>
+          <a:ln>
+            <a:noFill/>
+          </a:ln>
+        </p:spPr>
+        <p:style>
+          <a:lnRef idx="1">
+            <a:schemeClr val="accent1"/>
+          </a:lnRef>
+          <a:fillRef idx="3">
+            <a:schemeClr val="accent1"/>
+          </a:fillRef>
+          <a:effectRef idx="2">
+            <a:schemeClr val="accent1"/>
+          </a:effectRef>
+          <a:fontRef idx="minor">
+            <a:schemeClr val="lt1"/>
+          </a:fontRef>
+        </p:style>
+        <p:txBody>
+          <a:bodyPr rtlCol="0" anchor="ctr"/>
+          <a:lstStyle/>
+          <a:p>
+            <a:pPr algn="ctr"/>
+          </a:p>
+        </p:txBody>
+      </p:sp>
+      <p:sp>
+        <p:nvSpPr>
+          <p:cNvPr id="8" name="Rectangle 7">
+            <a:hlinkClick r:id="rId7"/>
+          </p:cNvPr>
+          <p:cNvSpPr/>
+          <p:nvPr/>
+        </p:nvSpPr>
+        <p:spPr>
+          <a:xfrm>
+            <a:off x="11750040" y="8183879"/>
+            <a:ext cx="2560320" cy="502920"/>
+          </a:xfrm>
+          <a:prstGeom prst="rect">
+            <a:avLst/>
+          </a:prstGeom>
+          <a:solidFill>
+            <a:srgbClr val="FFFFFF"/>
+          </a:solidFill>
+          <a:ln>
+            <a:noFill/>
+          </a:ln>
+        </p:spPr>
+        <p:style>
+          <a:lnRef idx="1">
+            <a:schemeClr val="accent1"/>
+          </a:lnRef>
+          <a:fillRef idx="3">
+            <a:schemeClr val="accent1"/>
+          </a:fillRef>
+          <a:effectRef idx="2">
+            <a:schemeClr val="accent1"/>
+          </a:effectRef>
+          <a:fontRef idx="minor">
+            <a:schemeClr val="lt1"/>
+          </a:fontRef>
+        </p:style>
+        <p:txBody>
+          <a:bodyPr rtlCol="0" anchor="ctr"/>
+          <a:lstStyle/>
+          <a:p>
+            <a:pPr algn="ctr"/>
+          </a:p>
+        </p:txBody>
+      </p:sp>
+      <p:sp>
+        <p:nvSpPr>
+          <p:cNvPr id="9" name="Rectangle 8">
+            <a:hlinkClick r:id="rId8"/>
+          </p:cNvPr>
+          <p:cNvSpPr/>
+          <p:nvPr/>
+        </p:nvSpPr>
+        <p:spPr>
+          <a:xfrm>
+            <a:off x="14785848" y="8183879"/>
+            <a:ext cx="2560320" cy="502920"/>
           </a:xfrm>
           <a:prstGeom prst="rect">
             <a:avLst/>
@@ -11421,6 +11869,96 @@
           </a:prstGeom>
         </p:spPr>
       </p:pic>
+      <p:sp>
+        <p:nvSpPr>
+          <p:cNvPr id="3" name="Rectangle 2">
+            <a:hlinkClick r:id="rId3"/>
+          </p:cNvPr>
+          <p:cNvSpPr/>
+          <p:nvPr/>
+        </p:nvSpPr>
+        <p:spPr>
+          <a:xfrm>
+            <a:off x="411480" y="9601200"/>
+            <a:ext cx="9144000" cy="411480"/>
+          </a:xfrm>
+          <a:prstGeom prst="rect">
+            <a:avLst/>
+          </a:prstGeom>
+          <a:solidFill>
+            <a:srgbClr val="FFFFFF"/>
+          </a:solidFill>
+          <a:ln>
+            <a:noFill/>
+          </a:ln>
+        </p:spPr>
+        <p:style>
+          <a:lnRef idx="1">
+            <a:schemeClr val="accent1"/>
+          </a:lnRef>
+          <a:fillRef idx="3">
+            <a:schemeClr val="accent1"/>
+          </a:fillRef>
+          <a:effectRef idx="2">
+            <a:schemeClr val="accent1"/>
+          </a:effectRef>
+          <a:fontRef idx="minor">
+            <a:schemeClr val="lt1"/>
+          </a:fontRef>
+        </p:style>
+        <p:txBody>
+          <a:bodyPr rtlCol="0" anchor="ctr"/>
+          <a:lstStyle/>
+          <a:p>
+            <a:pPr algn="ctr"/>
+          </a:p>
+        </p:txBody>
+      </p:sp>
+      <p:sp>
+        <p:nvSpPr>
+          <p:cNvPr id="4" name="Rectangle 3">
+            <a:hlinkClick r:id="rId4"/>
+          </p:cNvPr>
+          <p:cNvSpPr/>
+          <p:nvPr/>
+        </p:nvSpPr>
+        <p:spPr>
+          <a:xfrm>
+            <a:off x="411480" y="3749039"/>
+            <a:ext cx="11430000" cy="685800"/>
+          </a:xfrm>
+          <a:prstGeom prst="rect">
+            <a:avLst/>
+          </a:prstGeom>
+          <a:solidFill>
+            <a:srgbClr val="FFFFFF"/>
+          </a:solidFill>
+          <a:ln>
+            <a:noFill/>
+          </a:ln>
+        </p:spPr>
+        <p:style>
+          <a:lnRef idx="1">
+            <a:schemeClr val="accent1"/>
+          </a:lnRef>
+          <a:fillRef idx="3">
+            <a:schemeClr val="accent1"/>
+          </a:fillRef>
+          <a:effectRef idx="2">
+            <a:schemeClr val="accent1"/>
+          </a:effectRef>
+          <a:fontRef idx="minor">
+            <a:schemeClr val="lt1"/>
+          </a:fontRef>
+        </p:style>
+        <p:txBody>
+          <a:bodyPr rtlCol="0" anchor="ctr"/>
+          <a:lstStyle/>
+          <a:p>
+            <a:pPr algn="ctr"/>
+          </a:p>
+        </p:txBody>
+      </p:sp>
     </p:spTree>
   </p:cSld>
   <p:clrMapOvr>
@@ -11473,143 +12011,8 @@
         </p:nvSpPr>
         <p:spPr>
           <a:xfrm>
-            <a:off x="411480" y="2468880"/>
-            <a:ext cx="17373600" cy="713232"/>
-          </a:xfrm>
-          <a:prstGeom prst="rect">
-            <a:avLst/>
-          </a:prstGeom>
-          <a:solidFill>
-            <a:srgbClr val="FFFFFF"/>
-          </a:solidFill>
-          <a:ln>
-            <a:noFill/>
-          </a:ln>
-        </p:spPr>
-        <p:style>
-          <a:lnRef idx="1">
-            <a:schemeClr val="accent1"/>
-          </a:lnRef>
-          <a:fillRef idx="3">
-            <a:schemeClr val="accent1"/>
-          </a:fillRef>
-          <a:effectRef idx="2">
-            <a:schemeClr val="accent1"/>
-          </a:effectRef>
-          <a:fontRef idx="minor">
-            <a:schemeClr val="lt1"/>
-          </a:fontRef>
-        </p:style>
-        <p:txBody>
-          <a:bodyPr rtlCol="0" anchor="ctr"/>
-          <a:lstStyle/>
-          <a:p>
-            <a:pPr algn="ctr"/>
-          </a:p>
-        </p:txBody>
-      </p:sp>
-      <p:sp>
-        <p:nvSpPr>
-          <p:cNvPr id="4" name="Rectangle 3">
-            <a:hlinkClick r:id="rId4"/>
-          </p:cNvPr>
-          <p:cNvSpPr/>
-          <p:nvPr/>
-        </p:nvSpPr>
-        <p:spPr>
-          <a:xfrm>
-            <a:off x="411480" y="3246120"/>
-            <a:ext cx="17373600" cy="713232"/>
-          </a:xfrm>
-          <a:prstGeom prst="rect">
-            <a:avLst/>
-          </a:prstGeom>
-          <a:solidFill>
-            <a:srgbClr val="FFFFFF"/>
-          </a:solidFill>
-          <a:ln>
-            <a:noFill/>
-          </a:ln>
-        </p:spPr>
-        <p:style>
-          <a:lnRef idx="1">
-            <a:schemeClr val="accent1"/>
-          </a:lnRef>
-          <a:fillRef idx="3">
-            <a:schemeClr val="accent1"/>
-          </a:fillRef>
-          <a:effectRef idx="2">
-            <a:schemeClr val="accent1"/>
-          </a:effectRef>
-          <a:fontRef idx="minor">
-            <a:schemeClr val="lt1"/>
-          </a:fontRef>
-        </p:style>
-        <p:txBody>
-          <a:bodyPr rtlCol="0" anchor="ctr"/>
-          <a:lstStyle/>
-          <a:p>
-            <a:pPr algn="ctr"/>
-          </a:p>
-        </p:txBody>
-      </p:sp>
-      <p:sp>
-        <p:nvSpPr>
-          <p:cNvPr id="5" name="Rectangle 4">
-            <a:hlinkClick r:id="rId5"/>
-          </p:cNvPr>
-          <p:cNvSpPr/>
-          <p:nvPr/>
-        </p:nvSpPr>
-        <p:spPr>
-          <a:xfrm>
-            <a:off x="411480" y="4023360"/>
-            <a:ext cx="17373600" cy="713232"/>
-          </a:xfrm>
-          <a:prstGeom prst="rect">
-            <a:avLst/>
-          </a:prstGeom>
-          <a:solidFill>
-            <a:srgbClr val="FFFFFF"/>
-          </a:solidFill>
-          <a:ln>
-            <a:noFill/>
-          </a:ln>
-        </p:spPr>
-        <p:style>
-          <a:lnRef idx="1">
-            <a:schemeClr val="accent1"/>
-          </a:lnRef>
-          <a:fillRef idx="3">
-            <a:schemeClr val="accent1"/>
-          </a:fillRef>
-          <a:effectRef idx="2">
-            <a:schemeClr val="accent1"/>
-          </a:effectRef>
-          <a:fontRef idx="minor">
-            <a:schemeClr val="lt1"/>
-          </a:fontRef>
-        </p:style>
-        <p:txBody>
-          <a:bodyPr rtlCol="0" anchor="ctr"/>
-          <a:lstStyle/>
-          <a:p>
-            <a:pPr algn="ctr"/>
-          </a:p>
-        </p:txBody>
-      </p:sp>
-      <p:sp>
-        <p:nvSpPr>
-          <p:cNvPr id="6" name="Rectangle 5">
-            <a:hlinkClick r:id="rId6"/>
-          </p:cNvPr>
-          <p:cNvSpPr/>
-          <p:nvPr/>
-        </p:nvSpPr>
-        <p:spPr>
-          <a:xfrm>
-            <a:off x="411480" y="4800600"/>
-            <a:ext cx="17373600" cy="713232"/>
+            <a:off x="411480" y="9601200"/>
+            <a:ext cx="9144000" cy="411480"/>
           </a:xfrm>
           <a:prstGeom prst="rect">
             <a:avLst/>
@@ -11685,6 +12088,276 @@
           </a:prstGeom>
         </p:spPr>
       </p:pic>
+      <p:sp>
+        <p:nvSpPr>
+          <p:cNvPr id="3" name="Rectangle 2">
+            <a:hlinkClick r:id="rId3"/>
+          </p:cNvPr>
+          <p:cNvSpPr/>
+          <p:nvPr/>
+        </p:nvSpPr>
+        <p:spPr>
+          <a:xfrm>
+            <a:off x="411480" y="2423160"/>
+            <a:ext cx="3657600" cy="713232"/>
+          </a:xfrm>
+          <a:prstGeom prst="rect">
+            <a:avLst/>
+          </a:prstGeom>
+          <a:solidFill>
+            <a:srgbClr val="FFFFFF"/>
+          </a:solidFill>
+          <a:ln>
+            <a:noFill/>
+          </a:ln>
+        </p:spPr>
+        <p:style>
+          <a:lnRef idx="1">
+            <a:schemeClr val="accent1"/>
+          </a:lnRef>
+          <a:fillRef idx="3">
+            <a:schemeClr val="accent1"/>
+          </a:fillRef>
+          <a:effectRef idx="2">
+            <a:schemeClr val="accent1"/>
+          </a:effectRef>
+          <a:fontRef idx="minor">
+            <a:schemeClr val="lt1"/>
+          </a:fontRef>
+        </p:style>
+        <p:txBody>
+          <a:bodyPr rtlCol="0" anchor="ctr"/>
+          <a:lstStyle/>
+          <a:p>
+            <a:pPr algn="ctr"/>
+          </a:p>
+        </p:txBody>
+      </p:sp>
+      <p:sp>
+        <p:nvSpPr>
+          <p:cNvPr id="4" name="Rectangle 3">
+            <a:hlinkClick r:id="rId4"/>
+          </p:cNvPr>
+          <p:cNvSpPr/>
+          <p:nvPr/>
+        </p:nvSpPr>
+        <p:spPr>
+          <a:xfrm>
+            <a:off x="411480" y="3172968"/>
+            <a:ext cx="3657600" cy="713232"/>
+          </a:xfrm>
+          <a:prstGeom prst="rect">
+            <a:avLst/>
+          </a:prstGeom>
+          <a:solidFill>
+            <a:srgbClr val="FFFFFF"/>
+          </a:solidFill>
+          <a:ln>
+            <a:noFill/>
+          </a:ln>
+        </p:spPr>
+        <p:style>
+          <a:lnRef idx="1">
+            <a:schemeClr val="accent1"/>
+          </a:lnRef>
+          <a:fillRef idx="3">
+            <a:schemeClr val="accent1"/>
+          </a:fillRef>
+          <a:effectRef idx="2">
+            <a:schemeClr val="accent1"/>
+          </a:effectRef>
+          <a:fontRef idx="minor">
+            <a:schemeClr val="lt1"/>
+          </a:fontRef>
+        </p:style>
+        <p:txBody>
+          <a:bodyPr rtlCol="0" anchor="ctr"/>
+          <a:lstStyle/>
+          <a:p>
+            <a:pPr algn="ctr"/>
+          </a:p>
+        </p:txBody>
+      </p:sp>
+      <p:sp>
+        <p:nvSpPr>
+          <p:cNvPr id="5" name="Rectangle 4">
+            <a:hlinkClick r:id="rId5"/>
+          </p:cNvPr>
+          <p:cNvSpPr/>
+          <p:nvPr/>
+        </p:nvSpPr>
+        <p:spPr>
+          <a:xfrm>
+            <a:off x="411480" y="3922776"/>
+            <a:ext cx="3657600" cy="713232"/>
+          </a:xfrm>
+          <a:prstGeom prst="rect">
+            <a:avLst/>
+          </a:prstGeom>
+          <a:solidFill>
+            <a:srgbClr val="FFFFFF"/>
+          </a:solidFill>
+          <a:ln>
+            <a:noFill/>
+          </a:ln>
+        </p:spPr>
+        <p:style>
+          <a:lnRef idx="1">
+            <a:schemeClr val="accent1"/>
+          </a:lnRef>
+          <a:fillRef idx="3">
+            <a:schemeClr val="accent1"/>
+          </a:fillRef>
+          <a:effectRef idx="2">
+            <a:schemeClr val="accent1"/>
+          </a:effectRef>
+          <a:fontRef idx="minor">
+            <a:schemeClr val="lt1"/>
+          </a:fontRef>
+        </p:style>
+        <p:txBody>
+          <a:bodyPr rtlCol="0" anchor="ctr"/>
+          <a:lstStyle/>
+          <a:p>
+            <a:pPr algn="ctr"/>
+          </a:p>
+        </p:txBody>
+      </p:sp>
+      <p:sp>
+        <p:nvSpPr>
+          <p:cNvPr id="6" name="Rectangle 5">
+            <a:hlinkClick r:id="rId6"/>
+          </p:cNvPr>
+          <p:cNvSpPr/>
+          <p:nvPr/>
+        </p:nvSpPr>
+        <p:spPr>
+          <a:xfrm>
+            <a:off x="411480" y="4672584"/>
+            <a:ext cx="3657600" cy="713232"/>
+          </a:xfrm>
+          <a:prstGeom prst="rect">
+            <a:avLst/>
+          </a:prstGeom>
+          <a:solidFill>
+            <a:srgbClr val="FFFFFF"/>
+          </a:solidFill>
+          <a:ln>
+            <a:noFill/>
+          </a:ln>
+        </p:spPr>
+        <p:style>
+          <a:lnRef idx="1">
+            <a:schemeClr val="accent1"/>
+          </a:lnRef>
+          <a:fillRef idx="3">
+            <a:schemeClr val="accent1"/>
+          </a:fillRef>
+          <a:effectRef idx="2">
+            <a:schemeClr val="accent1"/>
+          </a:effectRef>
+          <a:fontRef idx="minor">
+            <a:schemeClr val="lt1"/>
+          </a:fontRef>
+        </p:style>
+        <p:txBody>
+          <a:bodyPr rtlCol="0" anchor="ctr"/>
+          <a:lstStyle/>
+          <a:p>
+            <a:pPr algn="ctr"/>
+          </a:p>
+        </p:txBody>
+      </p:sp>
+      <p:sp>
+        <p:nvSpPr>
+          <p:cNvPr id="7" name="Rectangle 6">
+            <a:hlinkClick r:id="rId7"/>
+          </p:cNvPr>
+          <p:cNvSpPr/>
+          <p:nvPr/>
+        </p:nvSpPr>
+        <p:spPr>
+          <a:xfrm>
+            <a:off x="411480" y="5422392"/>
+            <a:ext cx="3657600" cy="713232"/>
+          </a:xfrm>
+          <a:prstGeom prst="rect">
+            <a:avLst/>
+          </a:prstGeom>
+          <a:solidFill>
+            <a:srgbClr val="FFFFFF"/>
+          </a:solidFill>
+          <a:ln>
+            <a:noFill/>
+          </a:ln>
+        </p:spPr>
+        <p:style>
+          <a:lnRef idx="1">
+            <a:schemeClr val="accent1"/>
+          </a:lnRef>
+          <a:fillRef idx="3">
+            <a:schemeClr val="accent1"/>
+          </a:fillRef>
+          <a:effectRef idx="2">
+            <a:schemeClr val="accent1"/>
+          </a:effectRef>
+          <a:fontRef idx="minor">
+            <a:schemeClr val="lt1"/>
+          </a:fontRef>
+        </p:style>
+        <p:txBody>
+          <a:bodyPr rtlCol="0" anchor="ctr"/>
+          <a:lstStyle/>
+          <a:p>
+            <a:pPr algn="ctr"/>
+          </a:p>
+        </p:txBody>
+      </p:sp>
+      <p:sp>
+        <p:nvSpPr>
+          <p:cNvPr id="8" name="Rectangle 7">
+            <a:hlinkClick r:id="rId8"/>
+          </p:cNvPr>
+          <p:cNvSpPr/>
+          <p:nvPr/>
+        </p:nvSpPr>
+        <p:spPr>
+          <a:xfrm>
+            <a:off x="411480" y="9601200"/>
+            <a:ext cx="7315200" cy="411480"/>
+          </a:xfrm>
+          <a:prstGeom prst="rect">
+            <a:avLst/>
+          </a:prstGeom>
+          <a:solidFill>
+            <a:srgbClr val="FFFFFF"/>
+          </a:solidFill>
+          <a:ln>
+            <a:noFill/>
+          </a:ln>
+        </p:spPr>
+        <p:style>
+          <a:lnRef idx="1">
+            <a:schemeClr val="accent1"/>
+          </a:lnRef>
+          <a:fillRef idx="3">
+            <a:schemeClr val="accent1"/>
+          </a:fillRef>
+          <a:effectRef idx="2">
+            <a:schemeClr val="accent1"/>
+          </a:effectRef>
+          <a:fontRef idx="minor">
+            <a:schemeClr val="lt1"/>
+          </a:fontRef>
+        </p:style>
+        <p:txBody>
+          <a:bodyPr rtlCol="0" anchor="ctr"/>
+          <a:lstStyle/>
+          <a:p>
+            <a:pPr algn="ctr"/>
+          </a:p>
+        </p:txBody>
+      </p:sp>
     </p:spTree>
   </p:cSld>
   <p:clrMapOvr>
@@ -11727,6 +12400,51 @@
           </a:prstGeom>
         </p:spPr>
       </p:pic>
+      <p:sp>
+        <p:nvSpPr>
+          <p:cNvPr id="3" name="Rectangle 2">
+            <a:hlinkClick r:id="rId3"/>
+          </p:cNvPr>
+          <p:cNvSpPr/>
+          <p:nvPr/>
+        </p:nvSpPr>
+        <p:spPr>
+          <a:xfrm>
+            <a:off x="411480" y="9601200"/>
+            <a:ext cx="7315200" cy="411480"/>
+          </a:xfrm>
+          <a:prstGeom prst="rect">
+            <a:avLst/>
+          </a:prstGeom>
+          <a:solidFill>
+            <a:srgbClr val="FFFFFF"/>
+          </a:solidFill>
+          <a:ln>
+            <a:noFill/>
+          </a:ln>
+        </p:spPr>
+        <p:style>
+          <a:lnRef idx="1">
+            <a:schemeClr val="accent1"/>
+          </a:lnRef>
+          <a:fillRef idx="3">
+            <a:schemeClr val="accent1"/>
+          </a:fillRef>
+          <a:effectRef idx="2">
+            <a:schemeClr val="accent1"/>
+          </a:effectRef>
+          <a:fontRef idx="minor">
+            <a:schemeClr val="lt1"/>
+          </a:fontRef>
+        </p:style>
+        <p:txBody>
+          <a:bodyPr rtlCol="0" anchor="ctr"/>
+          <a:lstStyle/>
+          <a:p>
+            <a:pPr algn="ctr"/>
+          </a:p>
+        </p:txBody>
+      </p:sp>
     </p:spTree>
   </p:cSld>
   <p:clrMapOvr>

</xml_diff>

<commit_message>
Add live Slayed It demo and source links
</commit_message>
<xml_diff>
--- a/DICE Challenge S3 - Slayed it Winning Submission.pptx
+++ b/DICE Challenge S3 - Slayed it Winning Submission.pptx
@@ -11184,7 +11184,7 @@
       <p:sp>
         <p:nvSpPr>
           <p:cNvPr id="4" name="Rectangle 3">
-            <a:hlinkClick r:id="rId3"/>
+            <a:hlinkClick r:id="rId4"/>
           </p:cNvPr>
           <p:cNvSpPr/>
           <p:nvPr/>
@@ -11229,7 +11229,7 @@
       <p:sp>
         <p:nvSpPr>
           <p:cNvPr id="5" name="Rectangle 4">
-            <a:hlinkClick r:id="rId4"/>
+            <a:hlinkClick r:id="rId5"/>
           </p:cNvPr>
           <p:cNvSpPr/>
           <p:nvPr/>
@@ -11274,7 +11274,7 @@
       <p:sp>
         <p:nvSpPr>
           <p:cNvPr id="6" name="Rectangle 5">
-            <a:hlinkClick r:id="rId5"/>
+            <a:hlinkClick r:id="rId6"/>
           </p:cNvPr>
           <p:cNvSpPr/>
           <p:nvPr/>
@@ -11319,7 +11319,7 @@
       <p:sp>
         <p:nvSpPr>
           <p:cNvPr id="7" name="Rectangle 6">
-            <a:hlinkClick r:id="rId6"/>
+            <a:hlinkClick r:id="rId7"/>
           </p:cNvPr>
           <p:cNvSpPr/>
           <p:nvPr/>
@@ -11364,7 +11364,7 @@
       <p:sp>
         <p:nvSpPr>
           <p:cNvPr id="8" name="Rectangle 7">
-            <a:hlinkClick r:id="rId7"/>
+            <a:hlinkClick r:id="rId8"/>
           </p:cNvPr>
           <p:cNvSpPr/>
           <p:nvPr/>
@@ -11409,7 +11409,7 @@
       <p:sp>
         <p:nvSpPr>
           <p:cNvPr id="9" name="Rectangle 8">
-            <a:hlinkClick r:id="rId8"/>
+            <a:hlinkClick r:id="rId9"/>
           </p:cNvPr>
           <p:cNvSpPr/>
           <p:nvPr/>
@@ -11745,6 +11745,51 @@
           <a:xfrm>
             <a:off x="411480" y="9601200"/>
             <a:ext cx="7315200" cy="411480"/>
+          </a:xfrm>
+          <a:prstGeom prst="rect">
+            <a:avLst/>
+          </a:prstGeom>
+          <a:solidFill>
+            <a:srgbClr val="FFFFFF"/>
+          </a:solidFill>
+          <a:ln>
+            <a:noFill/>
+          </a:ln>
+        </p:spPr>
+        <p:style>
+          <a:lnRef idx="1">
+            <a:schemeClr val="accent1"/>
+          </a:lnRef>
+          <a:fillRef idx="3">
+            <a:schemeClr val="accent1"/>
+          </a:fillRef>
+          <a:effectRef idx="2">
+            <a:schemeClr val="accent1"/>
+          </a:effectRef>
+          <a:fontRef idx="minor">
+            <a:schemeClr val="lt1"/>
+          </a:fontRef>
+        </p:style>
+        <p:txBody>
+          <a:bodyPr rtlCol="0" anchor="ctr"/>
+          <a:lstStyle/>
+          <a:p>
+            <a:pPr algn="ctr"/>
+          </a:p>
+        </p:txBody>
+      </p:sp>
+      <p:sp>
+        <p:nvSpPr>
+          <p:cNvPr id="116" name="Rectangle 115">
+            <a:hlinkClick r:id="rId8"/>
+          </p:cNvPr>
+          <p:cNvSpPr/>
+          <p:nvPr/>
+        </p:nvSpPr>
+        <p:spPr>
+          <a:xfrm>
+            <a:off x="13898880" y="8915400"/>
+            <a:ext cx="3840480" cy="502920"/>
           </a:xfrm>
           <a:prstGeom prst="rect">
             <a:avLst/>

</xml_diff>

<commit_message>
Strengthen solved case and business case
</commit_message>
<xml_diff>
--- a/DICE Challenge S3 - Slayed it Winning Submission.pptx
+++ b/DICE Challenge S3 - Slayed it Winning Submission.pptx
@@ -11191,8 +11191,8 @@
         </p:nvSpPr>
         <p:spPr>
           <a:xfrm>
-            <a:off x="11750040" y="6885432"/>
-            <a:ext cx="2560320" cy="502920"/>
+            <a:off x="11320272" y="2057400"/>
+            <a:ext cx="3127248" cy="822960"/>
           </a:xfrm>
           <a:prstGeom prst="rect">
             <a:avLst/>
@@ -11236,8 +11236,8 @@
         </p:nvSpPr>
         <p:spPr>
           <a:xfrm>
-            <a:off x="14785848" y="6885432"/>
-            <a:ext cx="2560320" cy="502920"/>
+            <a:off x="14648688" y="2057400"/>
+            <a:ext cx="3127248" cy="822960"/>
           </a:xfrm>
           <a:prstGeom prst="rect">
             <a:avLst/>
@@ -11281,8 +11281,8 @@
         </p:nvSpPr>
         <p:spPr>
           <a:xfrm>
-            <a:off x="11750040" y="7534656"/>
-            <a:ext cx="2560320" cy="502920"/>
+            <a:off x="11320272" y="3026664"/>
+            <a:ext cx="3127248" cy="822960"/>
           </a:xfrm>
           <a:prstGeom prst="rect">
             <a:avLst/>
@@ -11326,8 +11326,8 @@
         </p:nvSpPr>
         <p:spPr>
           <a:xfrm>
-            <a:off x="14785848" y="7534656"/>
-            <a:ext cx="2560320" cy="502920"/>
+            <a:off x="14648688" y="3026664"/>
+            <a:ext cx="3127248" cy="822960"/>
           </a:xfrm>
           <a:prstGeom prst="rect">
             <a:avLst/>
@@ -11371,8 +11371,8 @@
         </p:nvSpPr>
         <p:spPr>
           <a:xfrm>
-            <a:off x="11750040" y="8183879"/>
-            <a:ext cx="2560320" cy="502920"/>
+            <a:off x="11320272" y="4005072"/>
+            <a:ext cx="3127248" cy="822960"/>
           </a:xfrm>
           <a:prstGeom prst="rect">
             <a:avLst/>
@@ -11416,8 +11416,8 @@
         </p:nvSpPr>
         <p:spPr>
           <a:xfrm>
-            <a:off x="14785848" y="8183879"/>
-            <a:ext cx="2560320" cy="502920"/>
+            <a:off x="14648688" y="4005072"/>
+            <a:ext cx="3127248" cy="822960"/>
           </a:xfrm>
           <a:prstGeom prst="rect">
             <a:avLst/>

</xml_diff>